<commit_message>
docs: fill submission PPT architecture slides + add demo script and storyboard
- PPT slide 6 (Technical Architecture): FE / Integration / Web / DAO / Database layers
  with the actual frameworks used per layer
- PPT slide 8 (Software Architecture): layered-monolith + state-machine description,
  plus a text lifecycle diagram and ER model
- PPT slide 10 (Solution Description): what it does + what makes it different
- PPT slide 14 (Workflow & Deployment): run/deploy steps + 4 embedded app screenshots
- PPT slide 17 (Additional Data): stack, run commands, demo logins, testing, AI roadmap
- docs/DEMO_SCRIPT.md: timed (<=5 min) click-by-click recording script
- docs/screenshots/: storyboard captures of the running app
</commit_message>
<xml_diff>
--- a/Level1_Submission_Template.pptx
+++ b/Level1_Submission_Template.pptx
@@ -4842,20 +4842,23 @@
         </p:nvSpPr>
         <p:spPr/>
         <p:txBody>
-          <a:bodyPr vert="horz" lIns="91440" tIns="45720" rIns="91440" bIns="45720" rtlCol="0" anchor="t">
+          <a:bodyPr vert="horz" lIns="91440" tIns="45720" rIns="91440" bIns="45720" rtlCol="0" anchor="t" wrap="square">
             <a:normAutofit/>
           </a:bodyPr>
           <a:lstStyle/>
           <a:p>
-            <a:r>
-              <a:rPr lang="en-US" sz="1800" i="1" dirty="0">
+            <a:pPr>
+              <a:spcAft>
+                <a:spcPts val="600"/>
+              </a:spcAft>
+            </a:pPr>
+            <a:r>
+              <a:rPr sz="1250" b="1">
                 <a:solidFill>
-                  <a:schemeClr val="accent5">
-                    <a:lumMod val="75000"/>
-                  </a:schemeClr>
+                  <a:srgbClr val="333333"/>
                 </a:solidFill>
               </a:rPr>
-              <a:t>Describe here the solution details and how it solves the problem statement. Provide a brief on what makes your solution special or different from other solutions.</a:t>
+              <a:t>Smart Quiz AI Hub centralizes MCQ creation, review and approval into one accountable pipeline — replacing the fragmented third-party tools the L&amp;TT team relies on today.</a:t>
             </a:r>
             <a:endParaRPr lang="en-US" sz="1800" i="1" dirty="0">
               <a:solidFill>
@@ -4866,6 +4869,111 @@
               <a:ea typeface="Calibri"/>
               <a:cs typeface="Calibri"/>
             </a:endParaRPr>
+          </a:p>
+          <a:p>
+            <a:pPr>
+              <a:spcAft>
+                <a:spcPts val="600"/>
+              </a:spcAft>
+            </a:pPr>
+            <a:r>
+              <a:rPr sz="1250" b="0">
+                <a:solidFill>
+                  <a:srgbClr val="333333"/>
+                </a:solidFill>
+              </a:rPr>
+              <a:t>SMEs author questions from an intuitive UI or by bulk-uploading an Excel template (Template_MCQs.xlsx) that is validated row-by-row and imported as drafts.</a:t>
+            </a:r>
+          </a:p>
+          <a:p>
+            <a:pPr>
+              <a:spcAft>
+                <a:spcPts val="600"/>
+              </a:spcAft>
+            </a:pPr>
+            <a:r>
+              <a:rPr sz="1250" b="0">
+                <a:solidFill>
+                  <a:srgbClr val="333333"/>
+                </a:solidFill>
+              </a:rPr>
+              <a:t>Every question carries a live status. SMEs track their work in 'My Questions'; rejected items show the reviewer's feedback inline and can be edited and resubmitted.</a:t>
+            </a:r>
+          </a:p>
+          <a:p>
+            <a:pPr>
+              <a:spcAft>
+                <a:spcPts val="600"/>
+              </a:spcAft>
+            </a:pPr>
+            <a:r>
+              <a:rPr sz="1250" b="0">
+                <a:solidFill>
+                  <a:srgbClr val="333333"/>
+                </a:solidFill>
+              </a:rPr>
+              <a:t>Admins manage the full question bank, edit any question (except another author's private draft), and assign reviewers. Reviewers see only what's assigned to them and must give a mandatory comment when rejecting.</a:t>
+            </a:r>
+          </a:p>
+          <a:p>
+            <a:pPr>
+              <a:spcAft>
+                <a:spcPts val="600"/>
+              </a:spcAft>
+            </a:pPr>
+            <a:r>
+              <a:rPr sz="1250" b="1">
+                <a:solidFill>
+                  <a:srgbClr val="333333"/>
+                </a:solidFill>
+              </a:rPr>
+              <a:t>What makes it different:</a:t>
+            </a:r>
+          </a:p>
+          <a:p>
+            <a:pPr lvl="1">
+              <a:spcAft>
+                <a:spcPts val="600"/>
+              </a:spcAft>
+            </a:pPr>
+            <a:r>
+              <a:rPr sz="1250" b="0">
+                <a:solidFill>
+                  <a:srgbClr val="333333"/>
+                </a:solidFill>
+              </a:rPr>
+              <a:t>A real state-machine guarantees no question reaches 'Approved' without passing a skill-matched, NON-author review — a genuine quality gate, not just status labels.</a:t>
+            </a:r>
+          </a:p>
+          <a:p>
+            <a:pPr lvl="1">
+              <a:spcAft>
+                <a:spcPts val="600"/>
+              </a:spcAft>
+            </a:pPr>
+            <a:r>
+              <a:rPr sz="1250" b="0">
+                <a:solidFill>
+                  <a:srgbClr val="333333"/>
+                </a:solidFill>
+              </a:rPr>
+              <a:t>Reviewer assignment is automatically restricted to SMEs whose skills match the question's technology stack, and excludes the creator to prevent self-review.</a:t>
+            </a:r>
+          </a:p>
+          <a:p>
+            <a:pPr lvl="1">
+              <a:spcAft>
+                <a:spcPts val="600"/>
+              </a:spcAft>
+            </a:pPr>
+            <a:r>
+              <a:rPr sz="1250" b="0">
+                <a:solidFill>
+                  <a:srgbClr val="333333"/>
+                </a:solidFill>
+              </a:rPr>
+              <a:t>Full, auditable review history across multiple revision cycles; zero-setup demo (H2 + seeded data) with a production PostgreSQL profile; 35 automated tests.</a:t>
+            </a:r>
           </a:p>
         </p:txBody>
       </p:sp>
@@ -7117,22 +7225,30 @@
             <p:ph idx="1"/>
           </p:nvPr>
         </p:nvSpPr>
-        <p:spPr/>
+        <p:spPr>
+          <a:xfrm>
+            <a:off x="548640" y="1554480"/>
+            <a:ext cx="4937760" cy="4754880"/>
+          </a:xfrm>
+        </p:spPr>
         <p:txBody>
-          <a:bodyPr vert="horz" lIns="91440" tIns="45720" rIns="91440" bIns="45720" rtlCol="0" anchor="t">
+          <a:bodyPr vert="horz" lIns="91440" tIns="45720" rIns="91440" bIns="45720" rtlCol="0" anchor="t" wrap="square">
             <a:normAutofit/>
           </a:bodyPr>
           <a:lstStyle/>
           <a:p>
-            <a:r>
-              <a:rPr lang="en-US" sz="1800" i="1" dirty="0">
+            <a:pPr>
+              <a:spcAft>
+                <a:spcPts val="500"/>
+              </a:spcAft>
+            </a:pPr>
+            <a:r>
+              <a:rPr sz="1300" b="1">
                 <a:solidFill>
-                  <a:schemeClr val="accent5">
-                    <a:lumMod val="75000"/>
-                  </a:schemeClr>
+                  <a:srgbClr val="1A2B4A"/>
                 </a:solidFill>
               </a:rPr>
-              <a:t>Provide screenshots of the solution and deployment instructions/dummy data if any .</a:t>
+              <a:t>Deployment / run instructions</a:t>
             </a:r>
             <a:endParaRPr lang="en-US" sz="1800" i="1" dirty="0">
               <a:solidFill>
@@ -7144,6 +7260,171 @@
               <a:cs typeface="Calibri"/>
             </a:endParaRPr>
           </a:p>
+          <a:p>
+            <a:pPr>
+              <a:spcAft>
+                <a:spcPts val="500"/>
+              </a:spcAft>
+            </a:pPr>
+            <a:r>
+              <a:rPr sz="1200" b="0">
+                <a:solidFill>
+                  <a:srgbClr val="333333"/>
+                </a:solidFill>
+              </a:rPr>
+              <a:t>1.  Backend: cd backend &amp;&amp; mvn spring-boot:run</a:t>
+            </a:r>
+          </a:p>
+          <a:p>
+            <a:pPr lvl="1">
+              <a:spcAft>
+                <a:spcPts val="500"/>
+              </a:spcAft>
+            </a:pPr>
+            <a:r>
+              <a:rPr sz="1200" b="0">
+                <a:solidFill>
+                  <a:srgbClr val="333333"/>
+                </a:solidFill>
+              </a:rPr>
+              <a:t>     → http://localhost:8080 (H2 auto-seeded)</a:t>
+            </a:r>
+          </a:p>
+          <a:p>
+            <a:pPr>
+              <a:spcAft>
+                <a:spcPts val="500"/>
+              </a:spcAft>
+            </a:pPr>
+            <a:r>
+              <a:rPr sz="1200" b="0">
+                <a:solidFill>
+                  <a:srgbClr val="333333"/>
+                </a:solidFill>
+              </a:rPr>
+              <a:t>2.  Frontend: cd frontend &amp;&amp; npm install &amp;&amp; npm run dev</a:t>
+            </a:r>
+          </a:p>
+          <a:p>
+            <a:pPr lvl="1">
+              <a:spcAft>
+                <a:spcPts val="500"/>
+              </a:spcAft>
+            </a:pPr>
+            <a:r>
+              <a:rPr sz="1200" b="0">
+                <a:solidFill>
+                  <a:srgbClr val="333333"/>
+                </a:solidFill>
+              </a:rPr>
+              <a:t>     → http://localhost:5173 (proxies /api to :8080)</a:t>
+            </a:r>
+          </a:p>
+          <a:p>
+            <a:pPr>
+              <a:spcAft>
+                <a:spcPts val="500"/>
+              </a:spcAft>
+            </a:pPr>
+            <a:r>
+              <a:rPr sz="1200" b="0">
+                <a:solidFill>
+                  <a:srgbClr val="333333"/>
+                </a:solidFill>
+              </a:rPr>
+              <a:t>3.  Sign in with a demo account (password = password):</a:t>
+            </a:r>
+          </a:p>
+          <a:p>
+            <a:pPr lvl="1">
+              <a:spcAft>
+                <a:spcPts val="500"/>
+              </a:spcAft>
+            </a:pPr>
+            <a:r>
+              <a:rPr sz="1200" b="0">
+                <a:solidFill>
+                  <a:srgbClr val="333333"/>
+                </a:solidFill>
+              </a:rPr>
+              <a:t>     birendra.kumar.singh = Admin; gaurav.a.bhola = SME</a:t>
+            </a:r>
+          </a:p>
+          <a:p>
+            <a:pPr>
+              <a:spcAft>
+                <a:spcPts val="500"/>
+              </a:spcAft>
+            </a:pPr>
+            <a:r>
+              <a:rPr sz="1200" b="0">
+                <a:solidFill>
+                  <a:srgbClr val="333333"/>
+                </a:solidFill>
+              </a:rPr>
+              <a:t>Optional: run on PostgreSQL with</a:t>
+            </a:r>
+          </a:p>
+          <a:p>
+            <a:pPr lvl="1">
+              <a:spcAft>
+                <a:spcPts val="500"/>
+              </a:spcAft>
+            </a:pPr>
+            <a:r>
+              <a:rPr sz="1200" b="0">
+                <a:solidFill>
+                  <a:srgbClr val="333333"/>
+                </a:solidFill>
+              </a:rPr>
+              <a:t>   mvn spring-boot:run -Dspring-boot.run.profiles=postgres</a:t>
+            </a:r>
+          </a:p>
+          <a:p>
+            <a:pPr>
+              <a:spcAft>
+                <a:spcPts val="500"/>
+              </a:spcAft>
+            </a:pPr>
+            <a:r>
+              <a:rPr sz="1300" b="1">
+                <a:solidFill>
+                  <a:srgbClr val="1A2B4A"/>
+                </a:solidFill>
+              </a:rPr>
+              <a:t>Workflow shown in screenshots →</a:t>
+            </a:r>
+          </a:p>
+          <a:p>
+            <a:pPr lvl="1">
+              <a:spcAft>
+                <a:spcPts val="500"/>
+              </a:spcAft>
+            </a:pPr>
+            <a:r>
+              <a:rPr sz="1200" b="0">
+                <a:solidFill>
+                  <a:srgbClr val="333333"/>
+                </a:solidFill>
+              </a:rPr>
+              <a:t>Login · My Questions (with statuses &amp; reviewer feedback) ·</a:t>
+            </a:r>
+          </a:p>
+          <a:p>
+            <a:pPr lvl="1">
+              <a:spcAft>
+                <a:spcPts val="500"/>
+              </a:spcAft>
+            </a:pPr>
+            <a:r>
+              <a:rPr sz="1200" b="0">
+                <a:solidFill>
+                  <a:srgbClr val="333333"/>
+                </a:solidFill>
+              </a:rPr>
+              <a:t>Add Question · Admin Question Bank (assign reviewer).</a:t>
+            </a:r>
+          </a:p>
         </p:txBody>
       </p:sp>
       <p:pic>
@@ -7179,6 +7460,102 @@
           <a:xfrm>
             <a:off x="9993085" y="681037"/>
             <a:ext cx="914400" cy="914400"/>
+          </a:xfrm>
+          <a:prstGeom prst="rect">
+            <a:avLst/>
+          </a:prstGeom>
+        </p:spPr>
+      </p:pic>
+      <p:pic>
+        <p:nvPicPr>
+          <p:cNvPr id="6" name="Picture 5" descr="01-login.png"/>
+          <p:cNvPicPr>
+            <a:picLocks noChangeAspect="1"/>
+          </p:cNvPicPr>
+          <p:nvPr/>
+        </p:nvPicPr>
+        <p:blipFill>
+          <a:blip r:embed="rId3"/>
+          <a:stretch>
+            <a:fillRect/>
+          </a:stretch>
+        </p:blipFill>
+        <p:spPr>
+          <a:xfrm>
+            <a:off x="5715000" y="1554480"/>
+            <a:ext cx="3108960" cy="1301472"/>
+          </a:xfrm>
+          <a:prstGeom prst="rect">
+            <a:avLst/>
+          </a:prstGeom>
+        </p:spPr>
+      </p:pic>
+      <p:pic>
+        <p:nvPicPr>
+          <p:cNvPr id="7" name="Picture 6" descr="02-my-questions.png"/>
+          <p:cNvPicPr>
+            <a:picLocks noChangeAspect="1"/>
+          </p:cNvPicPr>
+          <p:nvPr/>
+        </p:nvPicPr>
+        <p:blipFill>
+          <a:blip r:embed="rId4"/>
+          <a:stretch>
+            <a:fillRect/>
+          </a:stretch>
+        </p:blipFill>
+        <p:spPr>
+          <a:xfrm>
+            <a:off x="9006840" y="1554480"/>
+            <a:ext cx="3108960" cy="1302320"/>
+          </a:xfrm>
+          <a:prstGeom prst="rect">
+            <a:avLst/>
+          </a:prstGeom>
+        </p:spPr>
+      </p:pic>
+      <p:pic>
+        <p:nvPicPr>
+          <p:cNvPr id="8" name="Picture 7" descr="03-add-question.png"/>
+          <p:cNvPicPr>
+            <a:picLocks noChangeAspect="1"/>
+          </p:cNvPicPr>
+          <p:nvPr/>
+        </p:nvPicPr>
+        <p:blipFill>
+          <a:blip r:embed="rId5"/>
+          <a:stretch>
+            <a:fillRect/>
+          </a:stretch>
+        </p:blipFill>
+        <p:spPr>
+          <a:xfrm>
+            <a:off x="5715000" y="4069080"/>
+            <a:ext cx="3108960" cy="1302320"/>
+          </a:xfrm>
+          <a:prstGeom prst="rect">
+            <a:avLst/>
+          </a:prstGeom>
+        </p:spPr>
+      </p:pic>
+      <p:pic>
+        <p:nvPicPr>
+          <p:cNvPr id="9" name="Picture 8" descr="04-question-bank.png"/>
+          <p:cNvPicPr>
+            <a:picLocks noChangeAspect="1"/>
+          </p:cNvPicPr>
+          <p:nvPr/>
+        </p:nvPicPr>
+        <p:blipFill>
+          <a:blip r:embed="rId6"/>
+          <a:stretch>
+            <a:fillRect/>
+          </a:stretch>
+        </p:blipFill>
+        <p:spPr>
+          <a:xfrm>
+            <a:off x="9006840" y="4069080"/>
+            <a:ext cx="3108960" cy="1302320"/>
           </a:xfrm>
           <a:prstGeom prst="rect">
             <a:avLst/>
@@ -8414,20 +8791,23 @@
         </p:nvSpPr>
         <p:spPr/>
         <p:txBody>
-          <a:bodyPr vert="horz" lIns="91440" tIns="45720" rIns="91440" bIns="45720" rtlCol="0" anchor="t">
+          <a:bodyPr vert="horz" lIns="91440" tIns="45720" rIns="91440" bIns="45720" rtlCol="0" anchor="t" wrap="square">
             <a:normAutofit/>
           </a:bodyPr>
           <a:lstStyle/>
           <a:p>
-            <a:r>
-              <a:rPr lang="en-US" sz="1800" i="1" dirty="0">
+            <a:pPr>
+              <a:spcAft>
+                <a:spcPts val="700"/>
+              </a:spcAft>
+            </a:pPr>
+            <a:r>
+              <a:rPr sz="1250" b="0">
                 <a:solidFill>
-                  <a:schemeClr val="accent5">
-                    <a:lumMod val="75000"/>
-                  </a:schemeClr>
+                  <a:srgbClr val="333333"/>
                 </a:solidFill>
               </a:rPr>
-              <a:t>Add any additional important points/artifacts related to your solution here.</a:t>
+              <a:t>Tech stack: Java 17, Spring Boot 3.2, Spring Security + JWT, Spring Data JPA/Hibernate, Apache POI, H2 / PostgreSQL  •  React 18, TypeScript, Vite, Framer Motion.</a:t>
             </a:r>
             <a:endParaRPr lang="en-US" sz="1800" i="1" dirty="0">
               <a:solidFill>
@@ -8438,6 +8818,96 @@
               <a:ea typeface="Calibri"/>
               <a:cs typeface="Calibri"/>
             </a:endParaRPr>
+          </a:p>
+          <a:p>
+            <a:pPr>
+              <a:spcAft>
+                <a:spcPts val="700"/>
+              </a:spcAft>
+            </a:pPr>
+            <a:r>
+              <a:rPr sz="1250" b="0">
+                <a:solidFill>
+                  <a:srgbClr val="333333"/>
+                </a:solidFill>
+              </a:rPr>
+              <a:t>Run locally — backend: 'cd backend &amp;&amp; mvn spring-boot:run' (http://localhost:8080).  Frontend: 'cd frontend &amp;&amp; npm install &amp;&amp; npm run dev' (http://localhost:5173).</a:t>
+            </a:r>
+          </a:p>
+          <a:p>
+            <a:pPr>
+              <a:spcAft>
+                <a:spcPts val="700"/>
+              </a:spcAft>
+            </a:pPr>
+            <a:r>
+              <a:rPr sz="1250" b="0">
+                <a:solidFill>
+                  <a:srgbClr val="333333"/>
+                </a:solidFill>
+              </a:rPr>
+              <a:t>Demo logins (password = 'password'): birendra.kumar.singh (ADMIN); gaurav.a.bhola, divya.madhanasekar, swati.avinash.nikam, indugu.hari.prasad (SME).</a:t>
+            </a:r>
+          </a:p>
+          <a:p>
+            <a:pPr>
+              <a:spcAft>
+                <a:spcPts val="700"/>
+              </a:spcAft>
+            </a:pPr>
+            <a:r>
+              <a:rPr sz="1250" b="0">
+                <a:solidFill>
+                  <a:srgbClr val="333333"/>
+                </a:solidFill>
+              </a:rPr>
+              <a:t>Seeded from the problem statement: 6 technology stacks, Spring Cloud topics, the SME-skill mapping, and the two sample MCQs — so the app is demoable the moment it starts.</a:t>
+            </a:r>
+          </a:p>
+          <a:p>
+            <a:pPr>
+              <a:spcAft>
+                <a:spcPts val="700"/>
+              </a:spcAft>
+            </a:pPr>
+            <a:r>
+              <a:rPr sz="1250" b="0">
+                <a:solidFill>
+                  <a:srgbClr val="333333"/>
+                </a:solidFill>
+              </a:rPr>
+              <a:t>Testing: 35 JUnit 5 / MockMvc tests (lifecycle, services, controllers, auth, bulk import), all green; verified end-to-end against the running application.</a:t>
+            </a:r>
+          </a:p>
+          <a:p>
+            <a:pPr>
+              <a:spcAft>
+                <a:spcPts val="700"/>
+              </a:spcAft>
+            </a:pPr>
+            <a:r>
+              <a:rPr sz="1250" b="0">
+                <a:solidFill>
+                  <a:srgbClr val="333333"/>
+                </a:solidFill>
+              </a:rPr>
+              <a:t>Packaging note: delete backend/target and frontend/node_modules before zipping (source stays well under the 10 MB limit).</a:t>
+            </a:r>
+          </a:p>
+          <a:p>
+            <a:pPr>
+              <a:spcAft>
+                <a:spcPts val="700"/>
+              </a:spcAft>
+            </a:pPr>
+            <a:r>
+              <a:rPr sz="1250" b="0">
+                <a:solidFill>
+                  <a:srgbClr val="333333"/>
+                </a:solidFill>
+              </a:rPr>
+              <a:t>AI roadmap (Phase 2): the architecture leaves a clean seam for Spring AI — question generation from a topic and duplicate/similarity detection at creation time.</a:t>
+            </a:r>
           </a:p>
         </p:txBody>
       </p:sp>
@@ -11806,8 +12276,8 @@
         </p:nvSpPr>
         <p:spPr>
           <a:xfrm>
-            <a:off x="2417501" y="2211233"/>
-            <a:ext cx="7356996" cy="565354"/>
+            <a:off x="1371600" y="2148840"/>
+            <a:ext cx="9418320" cy="713232"/>
           </a:xfrm>
           <a:prstGeom prst="roundRect">
             <a:avLst/>
@@ -11828,24 +12298,21 @@
           </a:fontRef>
         </p:style>
         <p:txBody>
-          <a:bodyPr rtlCol="0" anchor="ctr"/>
+          <a:bodyPr rtlCol="0" anchor="ctr" wrap="square"/>
           <a:lstStyle/>
           <a:p>
-            <a:pPr algn="ctr" defTabSz="941832">
+            <a:pPr algn="l" defTabSz="941832">
               <a:spcAft>
                 <a:spcPts val="600"/>
               </a:spcAft>
             </a:pPr>
             <a:r>
-              <a:rPr lang="en-US" sz="1854" kern="1200">
+              <a:rPr sz="1100">
                 <a:solidFill>
-                  <a:srgbClr val="555555"/>
+                  <a:srgbClr val="FFFFFF"/>
                 </a:solidFill>
-                <a:latin typeface="+mn-lt"/>
-                <a:ea typeface="+mn-ea"/>
-                <a:cs typeface="+mn-cs"/>
               </a:rPr>
-              <a:t>FRONT END  - &lt;ADD CONTENT HERE&gt;</a:t>
+              <a:t>FRONT END  -  React 18 + TypeScript, Vite, React Router, Framer Motion (animations), custom design-system CSS. Talks to the API over REST/JSON with a JWT bearer token.</a:t>
             </a:r>
             <a:endParaRPr lang="en-US"/>
           </a:p>
@@ -11865,8 +12332,8 @@
         </p:nvSpPr>
         <p:spPr>
           <a:xfrm>
-            <a:off x="2417500" y="3038367"/>
-            <a:ext cx="7356997" cy="565354"/>
+            <a:off x="1371600" y="2971800"/>
+            <a:ext cx="9418320" cy="713232"/>
           </a:xfrm>
           <a:prstGeom prst="roundRect">
             <a:avLst/>
@@ -11887,24 +12354,21 @@
           </a:fontRef>
         </p:style>
         <p:txBody>
-          <a:bodyPr rtlCol="0" anchor="ctr"/>
+          <a:bodyPr rtlCol="0" anchor="ctr" wrap="square"/>
           <a:lstStyle/>
           <a:p>
-            <a:pPr algn="ctr" defTabSz="941832">
+            <a:pPr algn="l" defTabSz="941832">
               <a:spcAft>
                 <a:spcPts val="600"/>
               </a:spcAft>
             </a:pPr>
             <a:r>
-              <a:rPr lang="en-US" sz="1854" kern="1200">
+              <a:rPr sz="1100">
                 <a:solidFill>
-                  <a:srgbClr val="555555"/>
+                  <a:srgbClr val="FFFFFF"/>
                 </a:solidFill>
-                <a:latin typeface="+mn-lt"/>
-                <a:ea typeface="+mn-ea"/>
-                <a:cs typeface="+mn-cs"/>
               </a:rPr>
-              <a:t>INTEGRATION LAYER  - &lt;ADD CONTENT HERE&gt;</a:t>
+              <a:t>INTEGRATION LAYER  -  Spring Security + JWT (stateless, role-based), CORS, REST controllers, Bean Validation, centralized exception handling (@RestControllerAdvice). Apache POI for Excel import/export.</a:t>
             </a:r>
             <a:endParaRPr lang="en-US"/>
           </a:p>
@@ -11924,8 +12388,8 @@
         </p:nvSpPr>
         <p:spPr>
           <a:xfrm>
-            <a:off x="2417501" y="3867774"/>
-            <a:ext cx="7356998" cy="565354"/>
+            <a:off x="1371600" y="3794760"/>
+            <a:ext cx="9418320" cy="713232"/>
           </a:xfrm>
           <a:prstGeom prst="roundRect">
             <a:avLst/>
@@ -11946,24 +12410,21 @@
           </a:fontRef>
         </p:style>
         <p:txBody>
-          <a:bodyPr rtlCol="0" anchor="ctr"/>
+          <a:bodyPr rtlCol="0" anchor="ctr" wrap="square"/>
           <a:lstStyle/>
           <a:p>
-            <a:pPr algn="ctr" defTabSz="941832">
+            <a:pPr algn="l" defTabSz="941832">
               <a:spcAft>
                 <a:spcPts val="600"/>
               </a:spcAft>
             </a:pPr>
             <a:r>
-              <a:rPr lang="en-US" sz="1854" kern="1200">
+              <a:rPr sz="1100">
                 <a:solidFill>
-                  <a:srgbClr val="555555"/>
+                  <a:srgbClr val="FFFFFF"/>
                 </a:solidFill>
-                <a:latin typeface="+mn-lt"/>
-                <a:ea typeface="+mn-ea"/>
-                <a:cs typeface="+mn-cs"/>
               </a:rPr>
-              <a:t>WEB LAYER  - &lt;ADD CONTENT HERE&gt;</a:t>
+              <a:t>WEB LAYER  -  Spring Boot 3 (Java 17) MVC REST controllers exposing /api/* endpoints for auth, MCQs, reviews, admin question-bank, master data and bulk upload.</a:t>
             </a:r>
             <a:endParaRPr lang="en-US"/>
           </a:p>
@@ -11983,8 +12444,8 @@
         </p:nvSpPr>
         <p:spPr>
           <a:xfrm>
-            <a:off x="2417501" y="4695862"/>
-            <a:ext cx="7356999" cy="565354"/>
+            <a:off x="1371600" y="4617720"/>
+            <a:ext cx="9418320" cy="713232"/>
           </a:xfrm>
           <a:prstGeom prst="roundRect">
             <a:avLst/>
@@ -12005,24 +12466,21 @@
           </a:fontRef>
         </p:style>
         <p:txBody>
-          <a:bodyPr rtlCol="0" anchor="ctr"/>
+          <a:bodyPr rtlCol="0" anchor="ctr" wrap="square"/>
           <a:lstStyle/>
           <a:p>
-            <a:pPr algn="ctr" defTabSz="941832">
+            <a:pPr algn="l" defTabSz="941832">
               <a:spcAft>
                 <a:spcPts val="600"/>
               </a:spcAft>
             </a:pPr>
             <a:r>
-              <a:rPr lang="en-US" sz="1854" kern="1200" dirty="0">
+              <a:rPr sz="1100">
                 <a:solidFill>
-                  <a:srgbClr val="555555"/>
+                  <a:srgbClr val="FFFFFF"/>
                 </a:solidFill>
-                <a:latin typeface="+mn-lt"/>
-                <a:ea typeface="+mn-ea"/>
-                <a:cs typeface="+mn-cs"/>
               </a:rPr>
-              <a:t>DAO/PERSISTENCE LAYER- &lt;ADD CONTENT HERE&gt;</a:t>
+              <a:t>DAO / PERSISTENCE LAYER  -  Spring Data JPA / Hibernate repositories; service layer with an MCQ lifecycle state-machine enforcing all status transitions.</a:t>
             </a:r>
             <a:endParaRPr lang="en-US" dirty="0"/>
           </a:p>
@@ -12042,8 +12500,8 @@
         </p:nvSpPr>
         <p:spPr>
           <a:xfrm>
-            <a:off x="2417501" y="5512218"/>
-            <a:ext cx="7356996" cy="565354"/>
+            <a:off x="1371600" y="5440680"/>
+            <a:ext cx="9418320" cy="713232"/>
           </a:xfrm>
           <a:prstGeom prst="roundRect">
             <a:avLst/>
@@ -12064,24 +12522,21 @@
           </a:fontRef>
         </p:style>
         <p:txBody>
-          <a:bodyPr rtlCol="0" anchor="ctr"/>
+          <a:bodyPr rtlCol="0" anchor="ctr" wrap="square"/>
           <a:lstStyle/>
           <a:p>
-            <a:pPr algn="ctr" defTabSz="941832">
+            <a:pPr algn="l" defTabSz="941832">
               <a:spcAft>
                 <a:spcPts val="600"/>
               </a:spcAft>
             </a:pPr>
             <a:r>
-              <a:rPr lang="en-US" sz="1854" kern="1200">
+              <a:rPr sz="1100">
                 <a:solidFill>
-                  <a:srgbClr val="555555"/>
+                  <a:srgbClr val="FFFFFF"/>
                 </a:solidFill>
-                <a:latin typeface="+mn-lt"/>
-                <a:ea typeface="+mn-ea"/>
-                <a:cs typeface="+mn-cs"/>
               </a:rPr>
-              <a:t>DATABASE  - &lt;ADD CONTENT HERE&gt;</a:t>
+              <a:t>DATABASE  -  H2 in-memory by default (zero-setup demo, auto-seeded) with a PostgreSQL profile for production. Entities: User, UserSkill, TechStack, Topic, Mcq, ReviewAssignment.</a:t>
             </a:r>
             <a:endParaRPr lang="en-US"/>
           </a:p>
@@ -13075,22 +13530,30 @@
             <p:ph idx="1"/>
           </p:nvPr>
         </p:nvSpPr>
-        <p:spPr/>
+        <p:spPr>
+          <a:xfrm>
+            <a:off x="548640" y="1691640"/>
+            <a:ext cx="5852160" cy="4572000"/>
+          </a:xfrm>
+        </p:spPr>
         <p:txBody>
-          <a:bodyPr vert="horz" lIns="91440" tIns="45720" rIns="91440" bIns="45720" rtlCol="0" anchor="t">
+          <a:bodyPr vert="horz" lIns="91440" tIns="45720" rIns="91440" bIns="45720" rtlCol="0" anchor="t" wrap="square">
             <a:normAutofit/>
           </a:bodyPr>
           <a:lstStyle/>
           <a:p>
-            <a:r>
-              <a:rPr lang="en-US" sz="1800" i="1" dirty="0">
+            <a:pPr>
+              <a:spcAft>
+                <a:spcPts val="700"/>
+              </a:spcAft>
+            </a:pPr>
+            <a:r>
+              <a:rPr sz="1300" b="1">
                 <a:solidFill>
-                  <a:schemeClr val="accent5">
-                    <a:lumMod val="75000"/>
-                  </a:schemeClr>
+                  <a:srgbClr val="333333"/>
                 </a:solidFill>
               </a:rPr>
-              <a:t>Describe on the next slide using diagrams or at least 5-6 sentences the high-level architecture of your solution. E.g. UML diagrams, ER diagram, microservice oriented architecture diagram, design patterns used if any etc.</a:t>
+              <a:t>High-level architecture — a layered, modular monolith (Controller → Service → Repository) with a clear feature-based package layout.</a:t>
             </a:r>
             <a:endParaRPr lang="en-US" sz="1800" i="1" dirty="0">
               <a:solidFill>
@@ -13103,15 +13566,79 @@
             </a:endParaRPr>
           </a:p>
           <a:p>
-            <a:endParaRPr lang="en-US" sz="1800" i="1" dirty="0">
-              <a:solidFill>
-                <a:schemeClr val="accent5">
-                  <a:lumMod val="75000"/>
-                </a:schemeClr>
-              </a:solidFill>
-              <a:ea typeface="Calibri"/>
-              <a:cs typeface="Calibri"/>
-            </a:endParaRPr>
+            <a:pPr>
+              <a:spcAft>
+                <a:spcPts val="700"/>
+              </a:spcAft>
+            </a:pPr>
+            <a:r>
+              <a:rPr sz="1300" b="0">
+                <a:solidFill>
+                  <a:srgbClr val="333333"/>
+                </a:solidFill>
+              </a:rPr>
+              <a:t>Design pattern at the core: a State-Machine (McqLifecycle) is the single owner of all MCQ status transitions. No other class mutates status, so illegal transitions are impossible by construction.</a:t>
+            </a:r>
+          </a:p>
+          <a:p>
+            <a:pPr lvl="1">
+              <a:spcAft>
+                <a:spcPts val="700"/>
+              </a:spcAft>
+            </a:pPr>
+            <a:r>
+              <a:rPr sz="1300" b="0">
+                <a:solidFill>
+                  <a:srgbClr val="333333"/>
+                </a:solidFill>
+              </a:rPr>
+              <a:t>Each MCQ moves through exactly one state: Draft → Ready for Review → Under Review → Approved / Rejected (with re-submission loops).</a:t>
+            </a:r>
+          </a:p>
+          <a:p>
+            <a:pPr>
+              <a:spcAft>
+                <a:spcPts val="700"/>
+              </a:spcAft>
+            </a:pPr>
+            <a:r>
+              <a:rPr sz="1300" b="0">
+                <a:solidFill>
+                  <a:srgbClr val="333333"/>
+                </a:solidFill>
+              </a:rPr>
+              <a:t>Other patterns: DTO mapping at the controller boundary; repository pattern via Spring Data JPA; role-based access enforced at both the URL layer (Spring Security) and the service layer (defense in depth).</a:t>
+            </a:r>
+          </a:p>
+          <a:p>
+            <a:pPr>
+              <a:spcAft>
+                <a:spcPts val="700"/>
+              </a:spcAft>
+            </a:pPr>
+            <a:r>
+              <a:rPr sz="1300" b="0">
+                <a:solidFill>
+                  <a:srgbClr val="333333"/>
+                </a:solidFill>
+              </a:rPr>
+              <a:t>Review history is modelled as separate ReviewAssignment rows, so multi-cycle reviews are fully auditable and prior reviewer feedback is preserved across resubmissions.</a:t>
+            </a:r>
+          </a:p>
+          <a:p>
+            <a:pPr>
+              <a:spcAft>
+                <a:spcPts val="700"/>
+              </a:spcAft>
+            </a:pPr>
+            <a:r>
+              <a:rPr sz="1300" b="0">
+                <a:solidFill>
+                  <a:srgbClr val="333333"/>
+                </a:solidFill>
+              </a:rPr>
+              <a:t>Quality: 35 automated tests (JUnit 5 + MockMvc) cover the lifecycle, services, controllers, auth and bulk import. Verified end-to-end against the running app.</a:t>
+            </a:r>
           </a:p>
         </p:txBody>
       </p:sp>
@@ -13154,6 +13681,227 @@
           </a:prstGeom>
         </p:spPr>
       </p:pic>
+      <p:sp>
+        <p:nvSpPr>
+          <p:cNvPr id="11" name="TextBox 10"/>
+          <p:cNvSpPr txBox="1"/>
+          <p:nvPr/>
+        </p:nvSpPr>
+        <p:spPr>
+          <a:xfrm>
+            <a:off x="6583680" y="1691640"/>
+            <a:ext cx="5120640" cy="4572000"/>
+          </a:xfrm>
+          <a:prstGeom prst="rect">
+            <a:avLst/>
+          </a:prstGeom>
+          <a:noFill/>
+        </p:spPr>
+        <p:txBody>
+          <a:bodyPr wrap="square">
+            <a:spAutoFit/>
+          </a:bodyPr>
+          <a:lstStyle/>
+          <a:p>
+            <a:r>
+              <a:rPr sz="1200" b="1">
+                <a:solidFill>
+                  <a:srgbClr val="1A2B4A"/>
+                </a:solidFill>
+                <a:latin typeface="Consolas"/>
+              </a:rPr>
+              <a:t>MCQ LIFECYCLE (state machine)</a:t>
+            </a:r>
+          </a:p>
+          <a:p>
+            <a:r>
+              <a:rPr sz="1050" b="0">
+                <a:solidFill>
+                  <a:srgbClr val="333333"/>
+                </a:solidFill>
+                <a:latin typeface="Consolas"/>
+              </a:rPr>
+              <a:t/>
+            </a:r>
+          </a:p>
+          <a:p>
+            <a:r>
+              <a:rPr sz="1050" b="0">
+                <a:solidFill>
+                  <a:srgbClr val="333333"/>
+                </a:solidFill>
+                <a:latin typeface="Consolas"/>
+              </a:rPr>
+              <a:t>  Draft ──Save&amp;Send──▶ Ready for Review</a:t>
+            </a:r>
+          </a:p>
+          <a:p>
+            <a:r>
+              <a:rPr sz="1050" b="0">
+                <a:solidFill>
+                  <a:srgbClr val="333333"/>
+                </a:solidFill>
+                <a:latin typeface="Consolas"/>
+              </a:rPr>
+              <a:t>    ▲                      │ assign</a:t>
+            </a:r>
+          </a:p>
+          <a:p>
+            <a:r>
+              <a:rPr sz="1050" b="0">
+                <a:solidFill>
+                  <a:srgbClr val="333333"/>
+                </a:solidFill>
+                <a:latin typeface="Consolas"/>
+              </a:rPr>
+              <a:t>    │                      ▼</a:t>
+            </a:r>
+          </a:p>
+          <a:p>
+            <a:r>
+              <a:rPr sz="1050" b="0">
+                <a:solidFill>
+                  <a:srgbClr val="333333"/>
+                </a:solidFill>
+                <a:latin typeface="Consolas"/>
+              </a:rPr>
+              <a:t>    │                 Under Review</a:t>
+            </a:r>
+          </a:p>
+          <a:p>
+            <a:r>
+              <a:rPr sz="1050" b="0">
+                <a:solidFill>
+                  <a:srgbClr val="333333"/>
+                </a:solidFill>
+                <a:latin typeface="Consolas"/>
+              </a:rPr>
+              <a:t>    │                  │        │</a:t>
+            </a:r>
+          </a:p>
+          <a:p>
+            <a:r>
+              <a:rPr sz="1050" b="0">
+                <a:solidFill>
+                  <a:srgbClr val="333333"/>
+                </a:solidFill>
+                <a:latin typeface="Consolas"/>
+              </a:rPr>
+              <a:t>    │          approve │        │ reject</a:t>
+            </a:r>
+          </a:p>
+          <a:p>
+            <a:r>
+              <a:rPr sz="1050" b="0">
+                <a:solidFill>
+                  <a:srgbClr val="333333"/>
+                </a:solidFill>
+                <a:latin typeface="Consolas"/>
+              </a:rPr>
+              <a:t>    │                  ▼        ▼</a:t>
+            </a:r>
+          </a:p>
+          <a:p>
+            <a:r>
+              <a:rPr sz="1050" b="0">
+                <a:solidFill>
+                  <a:srgbClr val="333333"/>
+                </a:solidFill>
+                <a:latin typeface="Consolas"/>
+              </a:rPr>
+              <a:t>    │            Approved    Rejected</a:t>
+            </a:r>
+          </a:p>
+          <a:p>
+            <a:r>
+              <a:rPr sz="1050" b="0">
+                <a:solidFill>
+                  <a:srgbClr val="333333"/>
+                </a:solidFill>
+                <a:latin typeface="Consolas"/>
+              </a:rPr>
+              <a:t>    └──── edit &amp; resubmit ──────┘</a:t>
+            </a:r>
+          </a:p>
+          <a:p>
+            <a:r>
+              <a:rPr sz="1050" b="0">
+                <a:solidFill>
+                  <a:srgbClr val="333333"/>
+                </a:solidFill>
+                <a:latin typeface="Consolas"/>
+              </a:rPr>
+              <a:t/>
+            </a:r>
+          </a:p>
+          <a:p>
+            <a:r>
+              <a:rPr sz="1200" b="1">
+                <a:solidFill>
+                  <a:srgbClr val="1A2B4A"/>
+                </a:solidFill>
+                <a:latin typeface="Consolas"/>
+              </a:rPr>
+              <a:t>DATA MODEL (ER)</a:t>
+            </a:r>
+          </a:p>
+          <a:p>
+            <a:r>
+              <a:rPr sz="1050" b="0">
+                <a:solidFill>
+                  <a:srgbClr val="333333"/>
+                </a:solidFill>
+                <a:latin typeface="Consolas"/>
+              </a:rPr>
+              <a:t/>
+            </a:r>
+          </a:p>
+          <a:p>
+            <a:r>
+              <a:rPr sz="1050" b="0">
+                <a:solidFill>
+                  <a:srgbClr val="333333"/>
+                </a:solidFill>
+                <a:latin typeface="Consolas"/>
+              </a:rPr>
+              <a:t>  User 1───* UserSkill *───1 TechStack</a:t>
+            </a:r>
+          </a:p>
+          <a:p>
+            <a:r>
+              <a:rPr sz="1050" b="0">
+                <a:solidFill>
+                  <a:srgbClr val="333333"/>
+                </a:solidFill>
+                <a:latin typeface="Consolas"/>
+              </a:rPr>
+              <a:t>  TechStack 1───* Topic</a:t>
+            </a:r>
+          </a:p>
+          <a:p>
+            <a:r>
+              <a:rPr sz="1050" b="0">
+                <a:solidFill>
+                  <a:srgbClr val="333333"/>
+                </a:solidFill>
+                <a:latin typeface="Consolas"/>
+              </a:rPr>
+              <a:t>  Mcq *───1 TechStack, Topic, User(creator)</a:t>
+            </a:r>
+          </a:p>
+          <a:p>
+            <a:r>
+              <a:rPr sz="1050" b="0">
+                <a:solidFill>
+                  <a:srgbClr val="333333"/>
+                </a:solidFill>
+                <a:latin typeface="Consolas"/>
+              </a:rPr>
+              <a:t>  Mcq 1───* ReviewAssignment *───1 User(reviewer)</a:t>
+            </a:r>
+          </a:p>
+        </p:txBody>
+      </p:sp>
     </p:spTree>
     <p:extLst>
       <p:ext uri="{BB962C8B-B14F-4D97-AF65-F5344CB8AC3E}">

</xml_diff>

<commit_message>
docs: add rendered architecture diagram to slide 8; fill team slides (ThinkOut)
- docs/diagram/architecture.html: one-page architecture diagram in the app's
  editorial aesthetic (layered stack + MCQ lifecycle state machine + ER model
  + patterns/quality), rendered to docs/diagram/architecture.png at 2560x1440
- PPT slide 8: replaced ASCII text box with the rendered diagram image
- PPT slide 3: team name 'ThinkOut'
- PPT slide 4: 4 members (Shirish Mahajan, Durgadas Choudhari, Rupesh Kumar,
  Saloni Sinha) with Accenture emails; career level / role-market left as
  fill-in markers
</commit_message>
<xml_diff>
--- a/Level1_Submission_Template.pptx
+++ b/Level1_Submission_Template.pptx
@@ -10637,27 +10637,23 @@
           <a:lstStyle/>
           <a:p>
             <a:r>
-              <a:rPr lang="en-US" sz="2000" i="1" dirty="0">
+              <a:rPr b="1" sz="1800">
                 <a:solidFill>
-                  <a:schemeClr val="tx1">
-                    <a:alpha val="80000"/>
-                  </a:schemeClr>
+                  <a:srgbClr val="24375C"/>
                 </a:solidFill>
               </a:rPr>
-              <a:t>Provide team name and team member details on the next slide.</a:t>
-            </a:r>
-          </a:p>
-          <a:p>
-            <a:pPr marL="0" indent="0">
-              <a:buNone/>
-            </a:pPr>
-            <a:endParaRPr lang="en-US" sz="2000" i="1" dirty="0">
-              <a:solidFill>
-                <a:schemeClr val="tx1">
-                  <a:alpha val="80000"/>
-                </a:schemeClr>
-              </a:solidFill>
-            </a:endParaRPr>
+              <a:t>Team name: ThinkOut</a:t>
+            </a:r>
+          </a:p>
+          <a:p>
+            <a:r>
+              <a:rPr sz="1400">
+                <a:solidFill>
+                  <a:srgbClr val="24375C"/>
+                </a:solidFill>
+              </a:rPr>
+              <a:t>Member details are on the next slide.</a:t>
+            </a:r>
           </a:p>
         </p:txBody>
       </p:sp>
@@ -11103,7 +11099,10 @@
                     <a:bodyPr/>
                     <a:lstStyle/>
                     <a:p>
-                      <a:endParaRPr lang="en-US"/>
+                      <a:r>
+                        <a:rPr sz="1300"/>
+                        <a:t>Shirish Mahajan</a:t>
+                      </a:r>
                     </a:p>
                   </a:txBody>
                   <a:tcPr/>
@@ -11113,7 +11112,10 @@
                     <a:bodyPr/>
                     <a:lstStyle/>
                     <a:p>
-                      <a:endParaRPr lang="en-US"/>
+                      <a:r>
+                        <a:rPr sz="1300"/>
+                        <a:t>s.shirish.mahajan@accenture.com</a:t>
+                      </a:r>
                     </a:p>
                   </a:txBody>
                   <a:tcPr/>
@@ -11123,7 +11125,10 @@
                     <a:bodyPr/>
                     <a:lstStyle/>
                     <a:p>
-                      <a:endParaRPr lang="en-US"/>
+                      <a:r>
+                        <a:rPr sz="1300"/>
+                        <a:t>&lt;career level&gt;</a:t>
+                      </a:r>
                     </a:p>
                   </a:txBody>
                   <a:tcPr/>
@@ -11133,7 +11138,10 @@
                     <a:bodyPr/>
                     <a:lstStyle/>
                     <a:p>
-                      <a:endParaRPr lang="en-US"/>
+                      <a:r>
+                        <a:rPr sz="1300"/>
+                        <a:t>&lt;role / market&gt;</a:t>
+                      </a:r>
                     </a:p>
                   </a:txBody>
                   <a:tcPr/>
@@ -11150,7 +11158,10 @@
                     <a:bodyPr/>
                     <a:lstStyle/>
                     <a:p>
-                      <a:endParaRPr lang="en-US"/>
+                      <a:r>
+                        <a:rPr sz="1300"/>
+                        <a:t>Durgadas Choudhari</a:t>
+                      </a:r>
                     </a:p>
                   </a:txBody>
                   <a:tcPr/>
@@ -11160,7 +11171,10 @@
                     <a:bodyPr/>
                     <a:lstStyle/>
                     <a:p>
-                      <a:endParaRPr lang="en-US"/>
+                      <a:r>
+                        <a:rPr sz="1300"/>
+                        <a:t>s.durgadas.choudhari@accenture.com</a:t>
+                      </a:r>
                     </a:p>
                   </a:txBody>
                   <a:tcPr/>
@@ -11170,7 +11184,10 @@
                     <a:bodyPr/>
                     <a:lstStyle/>
                     <a:p>
-                      <a:endParaRPr lang="en-US"/>
+                      <a:r>
+                        <a:rPr sz="1300"/>
+                        <a:t>&lt;career level&gt;</a:t>
+                      </a:r>
                     </a:p>
                   </a:txBody>
                   <a:tcPr/>
@@ -11180,7 +11197,10 @@
                     <a:bodyPr/>
                     <a:lstStyle/>
                     <a:p>
-                      <a:endParaRPr lang="en-US"/>
+                      <a:r>
+                        <a:rPr sz="1300"/>
+                        <a:t>&lt;role / market&gt;</a:t>
+                      </a:r>
                     </a:p>
                   </a:txBody>
                   <a:tcPr/>
@@ -11197,7 +11217,10 @@
                     <a:bodyPr/>
                     <a:lstStyle/>
                     <a:p>
-                      <a:endParaRPr lang="en-US"/>
+                      <a:r>
+                        <a:rPr sz="1300"/>
+                        <a:t>Rupesh Kumar</a:t>
+                      </a:r>
                     </a:p>
                   </a:txBody>
                   <a:tcPr/>
@@ -11207,7 +11230,10 @@
                     <a:bodyPr/>
                     <a:lstStyle/>
                     <a:p>
-                      <a:endParaRPr lang="en-US"/>
+                      <a:r>
+                        <a:rPr sz="1300"/>
+                        <a:t>rupesh.v.kumar@accenture.com</a:t>
+                      </a:r>
                     </a:p>
                   </a:txBody>
                   <a:tcPr/>
@@ -11217,7 +11243,10 @@
                     <a:bodyPr/>
                     <a:lstStyle/>
                     <a:p>
-                      <a:endParaRPr lang="en-US"/>
+                      <a:r>
+                        <a:rPr sz="1300"/>
+                        <a:t>&lt;career level&gt;</a:t>
+                      </a:r>
                     </a:p>
                   </a:txBody>
                   <a:tcPr/>
@@ -11227,7 +11256,10 @@
                     <a:bodyPr/>
                     <a:lstStyle/>
                     <a:p>
-                      <a:endParaRPr lang="en-US"/>
+                      <a:r>
+                        <a:rPr sz="1300"/>
+                        <a:t>&lt;role / market&gt;</a:t>
+                      </a:r>
                     </a:p>
                   </a:txBody>
                   <a:tcPr/>
@@ -11244,7 +11276,10 @@
                     <a:bodyPr/>
                     <a:lstStyle/>
                     <a:p>
-                      <a:endParaRPr lang="en-US"/>
+                      <a:r>
+                        <a:rPr sz="1300"/>
+                        <a:t>Saloni Sinha</a:t>
+                      </a:r>
                     </a:p>
                   </a:txBody>
                   <a:tcPr/>
@@ -11254,7 +11289,10 @@
                     <a:bodyPr/>
                     <a:lstStyle/>
                     <a:p>
-                      <a:endParaRPr lang="en-US"/>
+                      <a:r>
+                        <a:rPr sz="1300"/>
+                        <a:t>saloni.c.sinha@accenture.com</a:t>
+                      </a:r>
                     </a:p>
                   </a:txBody>
                   <a:tcPr/>
@@ -11264,7 +11302,10 @@
                     <a:bodyPr/>
                     <a:lstStyle/>
                     <a:p>
-                      <a:endParaRPr lang="en-US"/>
+                      <a:r>
+                        <a:rPr sz="1300"/>
+                        <a:t>&lt;career level&gt;</a:t>
+                      </a:r>
                     </a:p>
                   </a:txBody>
                   <a:tcPr/>
@@ -11274,7 +11315,10 @@
                     <a:bodyPr/>
                     <a:lstStyle/>
                     <a:p>
-                      <a:endParaRPr lang="en-US" dirty="0"/>
+                      <a:r>
+                        <a:rPr sz="1300"/>
+                        <a:t>&lt;role / market&gt;</a:t>
+                      </a:r>
                     </a:p>
                   </a:txBody>
                   <a:tcPr/>
@@ -13532,8 +13576,8 @@
         </p:nvSpPr>
         <p:spPr>
           <a:xfrm>
-            <a:off x="548640" y="1691640"/>
-            <a:ext cx="5852160" cy="4572000"/>
+            <a:off x="502920" y="1645920"/>
+            <a:ext cx="5212080" cy="4663440"/>
           </a:xfrm>
         </p:spPr>
         <p:txBody>
@@ -13681,227 +13725,30 @@
           </a:prstGeom>
         </p:spPr>
       </p:pic>
-      <p:sp>
-        <p:nvSpPr>
-          <p:cNvPr id="11" name="TextBox 10"/>
-          <p:cNvSpPr txBox="1"/>
+      <p:pic>
+        <p:nvPicPr>
+          <p:cNvPr id="11" name="Picture 10" descr="architecture.png"/>
+          <p:cNvPicPr>
+            <a:picLocks noChangeAspect="1"/>
+          </p:cNvPicPr>
           <p:nvPr/>
-        </p:nvSpPr>
+        </p:nvPicPr>
+        <p:blipFill>
+          <a:blip r:embed="rId3"/>
+          <a:stretch>
+            <a:fillRect/>
+          </a:stretch>
+        </p:blipFill>
         <p:spPr>
           <a:xfrm>
-            <a:off x="6583680" y="1691640"/>
-            <a:ext cx="5120640" cy="4572000"/>
+            <a:off x="5897880" y="2377440"/>
+            <a:ext cx="6126480" cy="3446145"/>
           </a:xfrm>
           <a:prstGeom prst="rect">
             <a:avLst/>
           </a:prstGeom>
-          <a:noFill/>
         </p:spPr>
-        <p:txBody>
-          <a:bodyPr wrap="square">
-            <a:spAutoFit/>
-          </a:bodyPr>
-          <a:lstStyle/>
-          <a:p>
-            <a:r>
-              <a:rPr sz="1200" b="1">
-                <a:solidFill>
-                  <a:srgbClr val="1A2B4A"/>
-                </a:solidFill>
-                <a:latin typeface="Consolas"/>
-              </a:rPr>
-              <a:t>MCQ LIFECYCLE (state machine)</a:t>
-            </a:r>
-          </a:p>
-          <a:p>
-            <a:r>
-              <a:rPr sz="1050" b="0">
-                <a:solidFill>
-                  <a:srgbClr val="333333"/>
-                </a:solidFill>
-                <a:latin typeface="Consolas"/>
-              </a:rPr>
-              <a:t/>
-            </a:r>
-          </a:p>
-          <a:p>
-            <a:r>
-              <a:rPr sz="1050" b="0">
-                <a:solidFill>
-                  <a:srgbClr val="333333"/>
-                </a:solidFill>
-                <a:latin typeface="Consolas"/>
-              </a:rPr>
-              <a:t>  Draft ──Save&amp;Send──▶ Ready for Review</a:t>
-            </a:r>
-          </a:p>
-          <a:p>
-            <a:r>
-              <a:rPr sz="1050" b="0">
-                <a:solidFill>
-                  <a:srgbClr val="333333"/>
-                </a:solidFill>
-                <a:latin typeface="Consolas"/>
-              </a:rPr>
-              <a:t>    ▲                      │ assign</a:t>
-            </a:r>
-          </a:p>
-          <a:p>
-            <a:r>
-              <a:rPr sz="1050" b="0">
-                <a:solidFill>
-                  <a:srgbClr val="333333"/>
-                </a:solidFill>
-                <a:latin typeface="Consolas"/>
-              </a:rPr>
-              <a:t>    │                      ▼</a:t>
-            </a:r>
-          </a:p>
-          <a:p>
-            <a:r>
-              <a:rPr sz="1050" b="0">
-                <a:solidFill>
-                  <a:srgbClr val="333333"/>
-                </a:solidFill>
-                <a:latin typeface="Consolas"/>
-              </a:rPr>
-              <a:t>    │                 Under Review</a:t>
-            </a:r>
-          </a:p>
-          <a:p>
-            <a:r>
-              <a:rPr sz="1050" b="0">
-                <a:solidFill>
-                  <a:srgbClr val="333333"/>
-                </a:solidFill>
-                <a:latin typeface="Consolas"/>
-              </a:rPr>
-              <a:t>    │                  │        │</a:t>
-            </a:r>
-          </a:p>
-          <a:p>
-            <a:r>
-              <a:rPr sz="1050" b="0">
-                <a:solidFill>
-                  <a:srgbClr val="333333"/>
-                </a:solidFill>
-                <a:latin typeface="Consolas"/>
-              </a:rPr>
-              <a:t>    │          approve │        │ reject</a:t>
-            </a:r>
-          </a:p>
-          <a:p>
-            <a:r>
-              <a:rPr sz="1050" b="0">
-                <a:solidFill>
-                  <a:srgbClr val="333333"/>
-                </a:solidFill>
-                <a:latin typeface="Consolas"/>
-              </a:rPr>
-              <a:t>    │                  ▼        ▼</a:t>
-            </a:r>
-          </a:p>
-          <a:p>
-            <a:r>
-              <a:rPr sz="1050" b="0">
-                <a:solidFill>
-                  <a:srgbClr val="333333"/>
-                </a:solidFill>
-                <a:latin typeface="Consolas"/>
-              </a:rPr>
-              <a:t>    │            Approved    Rejected</a:t>
-            </a:r>
-          </a:p>
-          <a:p>
-            <a:r>
-              <a:rPr sz="1050" b="0">
-                <a:solidFill>
-                  <a:srgbClr val="333333"/>
-                </a:solidFill>
-                <a:latin typeface="Consolas"/>
-              </a:rPr>
-              <a:t>    └──── edit &amp; resubmit ──────┘</a:t>
-            </a:r>
-          </a:p>
-          <a:p>
-            <a:r>
-              <a:rPr sz="1050" b="0">
-                <a:solidFill>
-                  <a:srgbClr val="333333"/>
-                </a:solidFill>
-                <a:latin typeface="Consolas"/>
-              </a:rPr>
-              <a:t/>
-            </a:r>
-          </a:p>
-          <a:p>
-            <a:r>
-              <a:rPr sz="1200" b="1">
-                <a:solidFill>
-                  <a:srgbClr val="1A2B4A"/>
-                </a:solidFill>
-                <a:latin typeface="Consolas"/>
-              </a:rPr>
-              <a:t>DATA MODEL (ER)</a:t>
-            </a:r>
-          </a:p>
-          <a:p>
-            <a:r>
-              <a:rPr sz="1050" b="0">
-                <a:solidFill>
-                  <a:srgbClr val="333333"/>
-                </a:solidFill>
-                <a:latin typeface="Consolas"/>
-              </a:rPr>
-              <a:t/>
-            </a:r>
-          </a:p>
-          <a:p>
-            <a:r>
-              <a:rPr sz="1050" b="0">
-                <a:solidFill>
-                  <a:srgbClr val="333333"/>
-                </a:solidFill>
-                <a:latin typeface="Consolas"/>
-              </a:rPr>
-              <a:t>  User 1───* UserSkill *───1 TechStack</a:t>
-            </a:r>
-          </a:p>
-          <a:p>
-            <a:r>
-              <a:rPr sz="1050" b="0">
-                <a:solidFill>
-                  <a:srgbClr val="333333"/>
-                </a:solidFill>
-                <a:latin typeface="Consolas"/>
-              </a:rPr>
-              <a:t>  TechStack 1───* Topic</a:t>
-            </a:r>
-          </a:p>
-          <a:p>
-            <a:r>
-              <a:rPr sz="1050" b="0">
-                <a:solidFill>
-                  <a:srgbClr val="333333"/>
-                </a:solidFill>
-                <a:latin typeface="Consolas"/>
-              </a:rPr>
-              <a:t>  Mcq *───1 TechStack, Topic, User(creator)</a:t>
-            </a:r>
-          </a:p>
-          <a:p>
-            <a:r>
-              <a:rPr sz="1050" b="0">
-                <a:solidFill>
-                  <a:srgbClr val="333333"/>
-                </a:solidFill>
-                <a:latin typeface="Consolas"/>
-              </a:rPr>
-              <a:t>  Mcq 1───* ReviewAssignment *───1 User(reviewer)</a:t>
-            </a:r>
-          </a:p>
-        </p:txBody>
-      </p:sp>
+      </p:pic>
     </p:spTree>
     <p:extLst>
       <p:ext uri="{BB962C8B-B14F-4D97-AF65-F5344CB8AC3E}">

</xml_diff>